<commit_message>
Update S3 vs GCS PPT to final version (13 slides, 11 dimensions)
- Replace with latest S3_vs_GCP.pptx from S3
- 11 comparison dimensions: storage classes, durability/consistency,
  pricing, egress, features, replication, GCP locations, high-perf
  buckets, S3 new features (Vectors/Files/Tables), encryption
</commit_message>
<xml_diff>
--- a/s3-vs-gcs-ppt/S3_vs_GCS.pptx
+++ b/s3-vs-gcs-ppt/S3_vs_GCS.pptx
@@ -5562,7 +5562,7 @@
                           </a:solidFill>
                           <a:latin typeface="Amazon Ember"/>
                         </a:rPr>
-                        <a:t>gcsfuse(≈AWS Mountpoint for S3：均为FUSE开源客户端) / Filestore(托管NFS但后端非对象存储)</a:t>
+                        <a:t>gcsfuse(FUSE非托管) / Filestore(托管NFS但后端非对象存储) / Rapid+FUSE(性能可对标)</a:t>
                       </a:r>
                     </a:p>
                   </a:txBody>
@@ -5762,7 +5762,7 @@
                 </a:solidFill>
                 <a:latin typeface="Amazon Ember"/>
               </a:rPr>
-              <a:t>正确的对标关系：gcsfuse ≈ AWS Mountpoint for Amazon S3(都是 FUSE、都是开源客户端)；而 S3 Files 是托管 NFS(基于EFS)，GCP 无等价物</a:t>
+              <a:t>S3 Vectors 是 AWS 差异化最明显的(GCP 无对象存储原生向量)；Files/Tables 是 GCP 有能力但架构层次/机制不同</a:t>
             </a:r>
           </a:p>
         </p:txBody>

</xml_diff>

<commit_message>
s3-vs-gcs: 新增第12页 访问控制&IAM对比(S3 Bucket Policy前缀授权 vs GCS IAM Conditions)
</commit_message>
<xml_diff>
--- a/s3-vs-gcs-ppt/S3_vs_GCS.pptx
+++ b/s3-vs-gcs-ppt/S3_vs_GCS.pptx
@@ -17,6 +17,7 @@
     <p:sldId id="265" r:id="rId16"/>
     <p:sldId id="266" r:id="rId17"/>
     <p:sldId id="267" r:id="rId18"/>
+    <p:sldId id="269" r:id="rId20"/>
     <p:sldId id="268" r:id="rId19"/>
   </p:sldIdLst>
   <p:sldSz cx="12191695" cy="6858000" type="screen4x3"/>
@@ -6500,6 +6501,791 @@
                 <a:latin typeface="Amazon Ember"/>
               </a:rPr>
               <a:t>13</a:t>
+            </a:r>
+          </a:p>
+        </p:txBody>
+      </p:sp>
+    </p:spTree>
+  </p:cSld>
+  <p:clrMapOvr>
+    <a:masterClrMapping/>
+  </p:clrMapOvr>
+</p:sld>
+</file>
+
+<file path=ppt/slides/slide14.xml><?xml version="1.0" encoding="utf-8"?>
+<p:sld xmlns:a="http://schemas.openxmlformats.org/drawingml/2006/main" xmlns:p="http://schemas.openxmlformats.org/presentationml/2006/main" xmlns:r="http://schemas.openxmlformats.org/officeDocument/2006/relationships">
+  <p:cSld>
+    <p:spTree>
+      <p:nvGrpSpPr>
+        <p:cNvPr id="1" name=""/>
+        <p:cNvGrpSpPr/>
+        <p:nvPr/>
+      </p:nvGrpSpPr>
+      <p:grpSpPr/>
+      <p:sp>
+        <p:nvSpPr>
+          <p:cNvPr id="2" name="Rectangle 1"/>
+          <p:cNvSpPr/>
+          <p:nvPr/>
+        </p:nvSpPr>
+        <p:spPr>
+          <a:xfrm>
+            <a:off x="0" y="0"/>
+            <a:ext cx="12188952" cy="960120"/>
+          </a:xfrm>
+          <a:prstGeom prst="rect">
+            <a:avLst/>
+          </a:prstGeom>
+          <a:solidFill>
+            <a:srgbClr val="232F3E"/>
+          </a:solidFill>
+          <a:ln>
+            <a:noFill/>
+          </a:ln>
+          <a:effectLst/>
+        </p:spPr>
+        <p:style>
+          <a:lnRef idx="1">
+            <a:schemeClr val="accent1"/>
+          </a:lnRef>
+          <a:fillRef idx="3">
+            <a:schemeClr val="accent1"/>
+          </a:fillRef>
+          <a:effectRef idx="2">
+            <a:schemeClr val="accent1"/>
+          </a:effectRef>
+          <a:fontRef idx="minor">
+            <a:schemeClr val="lt1"/>
+          </a:fontRef>
+        </p:style>
+        <p:txBody>
+          <a:bodyPr rtlCol="0" anchor="ctr"/>
+          <a:lstStyle/>
+          <a:p>
+            <a:pPr algn="ctr"/>
+          </a:p>
+        </p:txBody>
+      </p:sp>
+      <p:sp>
+        <p:nvSpPr>
+          <p:cNvPr id="3" name="Rectangle 2"/>
+          <p:cNvSpPr/>
+          <p:nvPr/>
+        </p:nvSpPr>
+        <p:spPr>
+          <a:xfrm>
+            <a:off x="0" y="960120"/>
+            <a:ext cx="12188952" cy="54864"/>
+          </a:xfrm>
+          <a:prstGeom prst="rect">
+            <a:avLst/>
+          </a:prstGeom>
+          <a:solidFill>
+            <a:srgbClr val="FF8500"/>
+          </a:solidFill>
+          <a:ln>
+            <a:noFill/>
+          </a:ln>
+          <a:effectLst/>
+        </p:spPr>
+        <p:style>
+          <a:lnRef idx="1">
+            <a:schemeClr val="accent1"/>
+          </a:lnRef>
+          <a:fillRef idx="3">
+            <a:schemeClr val="accent1"/>
+          </a:fillRef>
+          <a:effectRef idx="2">
+            <a:schemeClr val="accent1"/>
+          </a:effectRef>
+          <a:fontRef idx="minor">
+            <a:schemeClr val="lt1"/>
+          </a:fontRef>
+        </p:style>
+        <p:txBody>
+          <a:bodyPr rtlCol="0" anchor="ctr"/>
+          <a:lstStyle/>
+          <a:p>
+            <a:pPr algn="ctr"/>
+          </a:p>
+        </p:txBody>
+      </p:sp>
+      <p:sp>
+        <p:nvSpPr>
+          <p:cNvPr id="4" name="TextBox 3"/>
+          <p:cNvSpPr txBox="1"/>
+          <p:nvPr/>
+        </p:nvSpPr>
+        <p:spPr>
+          <a:xfrm>
+            <a:off x="502920" y="109728"/>
+            <a:ext cx="11155680" cy="603504"/>
+          </a:xfrm>
+          <a:prstGeom prst="rect">
+            <a:avLst/>
+          </a:prstGeom>
+          <a:noFill/>
+        </p:spPr>
+        <p:txBody>
+          <a:bodyPr wrap="square" anchor="t">
+            <a:spAutoFit/>
+          </a:bodyPr>
+          <a:lstStyle/>
+          <a:p>
+            <a:pPr algn="l"/>
+            <a:r>
+              <a:rPr sz="2800" b="1">
+                <a:solidFill>
+                  <a:srgbClr val="FFFFFF"/>
+                </a:solidFill>
+                <a:latin typeface="Amazon Ember Heavy"/>
+              </a:rPr>
+              <a:t>⑫ 访问控制 &amp; IAM 对比</a:t>
+            </a:r>
+          </a:p>
+        </p:txBody>
+      </p:sp>
+      <p:sp>
+        <p:nvSpPr>
+          <p:cNvPr id="5" name="TextBox 4"/>
+          <p:cNvSpPr txBox="1"/>
+          <p:nvPr/>
+        </p:nvSpPr>
+        <p:spPr>
+          <a:xfrm>
+            <a:off x="502920" y="658368"/>
+            <a:ext cx="11155680" cy="274320"/>
+          </a:xfrm>
+          <a:prstGeom prst="rect">
+            <a:avLst/>
+          </a:prstGeom>
+          <a:noFill/>
+        </p:spPr>
+        <p:txBody>
+          <a:bodyPr wrap="square" anchor="t">
+            <a:spAutoFit/>
+          </a:bodyPr>
+          <a:lstStyle/>
+          <a:p>
+            <a:pPr algn="l"/>
+            <a:r>
+              <a:rPr sz="1400" b="0">
+                <a:solidFill>
+                  <a:srgbClr val="C9D2DE"/>
+                </a:solidFill>
+                <a:latin typeface="Amazon Ember"/>
+              </a:rPr>
+              <a:t>授权模型 · 前缀级授权 · 临时访问 —— 基于官方文档核实</a:t>
+            </a:r>
+          </a:p>
+        </p:txBody>
+      </p:sp>
+      <p:graphicFrame>
+        <p:nvGraphicFramePr>
+          <p:cNvPr id="6" name="Table 5"/>
+          <p:cNvGraphicFramePr>
+            <a:graphicFrameLocks noGrp="1"/>
+          </p:cNvGraphicFramePr>
+          <p:nvPr/>
+        </p:nvGraphicFramePr>
+        <p:xfrm>
+          <a:off x="502920" y="1234440"/>
+          <a:ext cx="11201400" cy="3566160"/>
+        </p:xfrm>
+        <a:graphic>
+          <a:graphicData uri="http://schemas.openxmlformats.org/drawingml/2006/table">
+            <a:tbl>
+              <a:tblPr firstRow="1" bandRow="1">
+                <a:tableStyleId>{5C22544A-7EE6-4342-B048-85BDC9FD1C3A}</a:tableStyleId>
+              </a:tblPr>
+              <a:tblGrid>
+                <a:gridCol w="2286000"/>
+                <a:gridCol w="4206240"/>
+                <a:gridCol w="4709160"/>
+              </a:tblGrid>
+              <a:tr h="509451">
+                <a:tc>
+                  <a:txBody>
+                    <a:bodyPr wrap="square"/>
+                    <a:lstStyle/>
+                    <a:p>
+                      <a:r>
+                        <a:rPr sz="1250" b="1">
+                          <a:solidFill>
+                            <a:srgbClr val="FFFFFF"/>
+                          </a:solidFill>
+                          <a:latin typeface="Amazon Ember"/>
+                        </a:rPr>
+                        <a:t>维度</a:t>
+                      </a:r>
+                    </a:p>
+                  </a:txBody>
+                  <a:tcPr marL="73152" marR="73152" marT="27432" marB="27432" anchor="ctr">
+                    <a:solidFill>
+                      <a:srgbClr val="232F3E"/>
+                    </a:solidFill>
+                  </a:tcPr>
+                </a:tc>
+                <a:tc>
+                  <a:txBody>
+                    <a:bodyPr wrap="square"/>
+                    <a:lstStyle/>
+                    <a:p>
+                      <a:r>
+                        <a:rPr sz="1250" b="1">
+                          <a:solidFill>
+                            <a:srgbClr val="FFFFFF"/>
+                          </a:solidFill>
+                          <a:latin typeface="Amazon Ember"/>
+                        </a:rPr>
+                        <a:t>AWS S3</a:t>
+                      </a:r>
+                    </a:p>
+                  </a:txBody>
+                  <a:tcPr marL="73152" marR="73152" marT="27432" marB="27432" anchor="ctr">
+                    <a:solidFill>
+                      <a:srgbClr val="232F3E"/>
+                    </a:solidFill>
+                  </a:tcPr>
+                </a:tc>
+                <a:tc>
+                  <a:txBody>
+                    <a:bodyPr wrap="square"/>
+                    <a:lstStyle/>
+                    <a:p>
+                      <a:r>
+                        <a:rPr sz="1250" b="1">
+                          <a:solidFill>
+                            <a:srgbClr val="FFFFFF"/>
+                          </a:solidFill>
+                          <a:latin typeface="Amazon Ember"/>
+                        </a:rPr>
+                        <a:t>GCP Cloud Storage</a:t>
+                      </a:r>
+                    </a:p>
+                  </a:txBody>
+                  <a:tcPr marL="73152" marR="73152" marT="27432" marB="27432" anchor="ctr">
+                    <a:solidFill>
+                      <a:srgbClr val="232F3E"/>
+                    </a:solidFill>
+                  </a:tcPr>
+                </a:tc>
+              </a:tr>
+              <a:tr h="509451">
+                <a:tc>
+                  <a:txBody>
+                    <a:bodyPr wrap="square"/>
+                    <a:lstStyle/>
+                    <a:p>
+                      <a:r>
+                        <a:rPr sz="1150" b="1">
+                          <a:solidFill>
+                            <a:srgbClr val="232F3E"/>
+                          </a:solidFill>
+                          <a:latin typeface="Amazon Ember"/>
+                        </a:rPr>
+                        <a:t>授权模型</a:t>
+                      </a:r>
+                    </a:p>
+                  </a:txBody>
+                  <a:tcPr marL="73152" marR="73152" marT="27432" marB="27432" anchor="ctr">
+                    <a:solidFill>
+                      <a:srgbClr val="FFFFFF"/>
+                    </a:solidFill>
+                  </a:tcPr>
+                </a:tc>
+                <a:tc>
+                  <a:txBody>
+                    <a:bodyPr wrap="square"/>
+                    <a:lstStyle/>
+                    <a:p>
+                      <a:r>
+                        <a:rPr sz="1150">
+                          <a:solidFill>
+                            <a:srgbClr val="1A2B4A"/>
+                          </a:solidFill>
+                          <a:latin typeface="Amazon Ember"/>
+                        </a:rPr>
+                        <a:t>IAM Policy + Bucket Policy(基于资源) + ACL</a:t>
+                      </a:r>
+                    </a:p>
+                  </a:txBody>
+                  <a:tcPr marL="73152" marR="73152" marT="27432" marB="27432" anchor="ctr">
+                    <a:solidFill>
+                      <a:srgbClr val="FFFFFF"/>
+                    </a:solidFill>
+                  </a:tcPr>
+                </a:tc>
+                <a:tc>
+                  <a:txBody>
+                    <a:bodyPr wrap="square"/>
+                    <a:lstStyle/>
+                    <a:p>
+                      <a:r>
+                        <a:rPr sz="1150">
+                          <a:solidFill>
+                            <a:srgbClr val="1A2B4A"/>
+                          </a:solidFill>
+                          <a:latin typeface="Amazon Ember"/>
+                        </a:rPr>
+                        <a:t>IAM(含 IAM Conditions) + ACL(legacy)；无 bucket policy</a:t>
+                      </a:r>
+                    </a:p>
+                  </a:txBody>
+                  <a:tcPr marL="73152" marR="73152" marT="27432" marB="27432" anchor="ctr">
+                    <a:solidFill>
+                      <a:srgbClr val="FFFFFF"/>
+                    </a:solidFill>
+                  </a:tcPr>
+                </a:tc>
+              </a:tr>
+              <a:tr h="509451">
+                <a:tc>
+                  <a:txBody>
+                    <a:bodyPr wrap="square"/>
+                    <a:lstStyle/>
+                    <a:p>
+                      <a:r>
+                        <a:rPr sz="1150" b="1">
+                          <a:solidFill>
+                            <a:srgbClr val="232F3E"/>
+                          </a:solidFill>
+                          <a:latin typeface="Amazon Ember"/>
+                        </a:rPr>
+                        <a:t>前缀级授权</a:t>
+                      </a:r>
+                    </a:p>
+                  </a:txBody>
+                  <a:tcPr marL="73152" marR="73152" marT="27432" marB="27432" anchor="ctr">
+                    <a:solidFill>
+                      <a:srgbClr val="F2F6FB"/>
+                    </a:solidFill>
+                  </a:tcPr>
+                </a:tc>
+                <a:tc>
+                  <a:txBody>
+                    <a:bodyPr wrap="square"/>
+                    <a:lstStyle/>
+                    <a:p>
+                      <a:r>
+                        <a:rPr sz="1150">
+                          <a:solidFill>
+                            <a:srgbClr val="1A2B4A"/>
+                          </a:solidFill>
+                          <a:latin typeface="Amazon Ember"/>
+                        </a:rPr>
+                        <a:t>Bucket Policy 直接写 Resource: bucket/prefix/*(原生直接)</a:t>
+                      </a:r>
+                    </a:p>
+                  </a:txBody>
+                  <a:tcPr marL="73152" marR="73152" marT="27432" marB="27432" anchor="ctr">
+                    <a:solidFill>
+                      <a:srgbClr val="F2F6FB"/>
+                    </a:solidFill>
+                  </a:tcPr>
+                </a:tc>
+                <a:tc>
+                  <a:txBody>
+                    <a:bodyPr wrap="square"/>
+                    <a:lstStyle/>
+                    <a:p>
+                      <a:r>
+                        <a:rPr sz="1150">
+                          <a:solidFill>
+                            <a:srgbClr val="1A2B4A"/>
+                          </a:solidFill>
+                          <a:latin typeface="Amazon Ember"/>
+                        </a:rPr>
+                        <a:t>IAM Conditions 的 resource.name 前缀条件(官方支持,机制不同)</a:t>
+                      </a:r>
+                    </a:p>
+                  </a:txBody>
+                  <a:tcPr marL="73152" marR="73152" marT="27432" marB="27432" anchor="ctr">
+                    <a:solidFill>
+                      <a:srgbClr val="F2F6FB"/>
+                    </a:solidFill>
+                  </a:tcPr>
+                </a:tc>
+              </a:tr>
+              <a:tr h="509451">
+                <a:tc>
+                  <a:txBody>
+                    <a:bodyPr wrap="square"/>
+                    <a:lstStyle/>
+                    <a:p>
+                      <a:r>
+                        <a:rPr sz="1150" b="1">
+                          <a:solidFill>
+                            <a:srgbClr val="232F3E"/>
+                          </a:solidFill>
+                          <a:latin typeface="Amazon Ember"/>
+                        </a:rPr>
+                        <a:t>统一 vs 细粒度</a:t>
+                      </a:r>
+                    </a:p>
+                  </a:txBody>
+                  <a:tcPr marL="73152" marR="73152" marT="27432" marB="27432" anchor="ctr">
+                    <a:solidFill>
+                      <a:srgbClr val="FFFFFF"/>
+                    </a:solidFill>
+                  </a:tcPr>
+                </a:tc>
+                <a:tc>
+                  <a:txBody>
+                    <a:bodyPr wrap="square"/>
+                    <a:lstStyle/>
+                    <a:p>
+                      <a:r>
+                        <a:rPr sz="1150">
+                          <a:solidFill>
+                            <a:srgbClr val="1A2B4A"/>
+                          </a:solidFill>
+                          <a:latin typeface="Amazon Ember"/>
+                        </a:rPr>
+                        <a:t>Bucket owner enforced(关闭 ACL,只用 IAM)</a:t>
+                      </a:r>
+                    </a:p>
+                  </a:txBody>
+                  <a:tcPr marL="73152" marR="73152" marT="27432" marB="27432" anchor="ctr">
+                    <a:solidFill>
+                      <a:srgbClr val="FFFFFF"/>
+                    </a:solidFill>
+                  </a:tcPr>
+                </a:tc>
+                <a:tc>
+                  <a:txBody>
+                    <a:bodyPr wrap="square"/>
+                    <a:lstStyle/>
+                    <a:p>
+                      <a:r>
+                        <a:rPr sz="1150">
+                          <a:solidFill>
+                            <a:srgbClr val="1A2B4A"/>
+                          </a:solidFill>
+                          <a:latin typeface="Amazon Ember"/>
+                        </a:rPr>
+                        <a:t>Uniform bucket-level access vs Fine-grained(IAM+ACL)</a:t>
+                      </a:r>
+                    </a:p>
+                  </a:txBody>
+                  <a:tcPr marL="73152" marR="73152" marT="27432" marB="27432" anchor="ctr">
+                    <a:solidFill>
+                      <a:srgbClr val="FFFFFF"/>
+                    </a:solidFill>
+                  </a:tcPr>
+                </a:tc>
+              </a:tr>
+              <a:tr h="509451">
+                <a:tc>
+                  <a:txBody>
+                    <a:bodyPr wrap="square"/>
+                    <a:lstStyle/>
+                    <a:p>
+                      <a:r>
+                        <a:rPr sz="1150" b="1">
+                          <a:solidFill>
+                            <a:srgbClr val="232F3E"/>
+                          </a:solidFill>
+                          <a:latin typeface="Amazon Ember"/>
+                        </a:rPr>
+                        <a:t>临时访问</a:t>
+                      </a:r>
+                    </a:p>
+                  </a:txBody>
+                  <a:tcPr marL="73152" marR="73152" marT="27432" marB="27432" anchor="ctr">
+                    <a:solidFill>
+                      <a:srgbClr val="F2F6FB"/>
+                    </a:solidFill>
+                  </a:tcPr>
+                </a:tc>
+                <a:tc>
+                  <a:txBody>
+                    <a:bodyPr wrap="square"/>
+                    <a:lstStyle/>
+                    <a:p>
+                      <a:r>
+                        <a:rPr sz="1150">
+                          <a:solidFill>
+                            <a:srgbClr val="1A2B4A"/>
+                          </a:solidFill>
+                          <a:latin typeface="Amazon Ember"/>
+                        </a:rPr>
+                        <a:t>Presigned URL</a:t>
+                      </a:r>
+                    </a:p>
+                  </a:txBody>
+                  <a:tcPr marL="73152" marR="73152" marT="27432" marB="27432" anchor="ctr">
+                    <a:solidFill>
+                      <a:srgbClr val="F2F6FB"/>
+                    </a:solidFill>
+                  </a:tcPr>
+                </a:tc>
+                <a:tc>
+                  <a:txBody>
+                    <a:bodyPr wrap="square"/>
+                    <a:lstStyle/>
+                    <a:p>
+                      <a:r>
+                        <a:rPr sz="1150">
+                          <a:solidFill>
+                            <a:srgbClr val="1A2B4A"/>
+                          </a:solidFill>
+                          <a:latin typeface="Amazon Ember"/>
+                        </a:rPr>
+                        <a:t>Signed URL / Signed Policy Document</a:t>
+                      </a:r>
+                    </a:p>
+                  </a:txBody>
+                  <a:tcPr marL="73152" marR="73152" marT="27432" marB="27432" anchor="ctr">
+                    <a:solidFill>
+                      <a:srgbClr val="F2F6FB"/>
+                    </a:solidFill>
+                  </a:tcPr>
+                </a:tc>
+              </a:tr>
+              <a:tr h="509451">
+                <a:tc>
+                  <a:txBody>
+                    <a:bodyPr wrap="square"/>
+                    <a:lstStyle/>
+                    <a:p>
+                      <a:r>
+                        <a:rPr sz="1150" b="1">
+                          <a:solidFill>
+                            <a:srgbClr val="232F3E"/>
+                          </a:solidFill>
+                          <a:latin typeface="Amazon Ember"/>
+                        </a:rPr>
+                        <a:t>防止公开</a:t>
+                      </a:r>
+                    </a:p>
+                  </a:txBody>
+                  <a:tcPr marL="73152" marR="73152" marT="27432" marB="27432" anchor="ctr">
+                    <a:solidFill>
+                      <a:srgbClr val="FFFFFF"/>
+                    </a:solidFill>
+                  </a:tcPr>
+                </a:tc>
+                <a:tc>
+                  <a:txBody>
+                    <a:bodyPr wrap="square"/>
+                    <a:lstStyle/>
+                    <a:p>
+                      <a:r>
+                        <a:rPr sz="1150">
+                          <a:solidFill>
+                            <a:srgbClr val="1A2B4A"/>
+                          </a:solidFill>
+                          <a:latin typeface="Amazon Ember"/>
+                        </a:rPr>
+                        <a:t>Block Public Access(账号/桶级)</a:t>
+                      </a:r>
+                    </a:p>
+                  </a:txBody>
+                  <a:tcPr marL="73152" marR="73152" marT="27432" marB="27432" anchor="ctr">
+                    <a:solidFill>
+                      <a:srgbClr val="FFFFFF"/>
+                    </a:solidFill>
+                  </a:tcPr>
+                </a:tc>
+                <a:tc>
+                  <a:txBody>
+                    <a:bodyPr wrap="square"/>
+                    <a:lstStyle/>
+                    <a:p>
+                      <a:r>
+                        <a:rPr sz="1150">
+                          <a:solidFill>
+                            <a:srgbClr val="1A2B4A"/>
+                          </a:solidFill>
+                          <a:latin typeface="Amazon Ember"/>
+                        </a:rPr>
+                        <a:t>Public Access Prevention(组织策略可强制)</a:t>
+                      </a:r>
+                    </a:p>
+                  </a:txBody>
+                  <a:tcPr marL="73152" marR="73152" marT="27432" marB="27432" anchor="ctr">
+                    <a:solidFill>
+                      <a:srgbClr val="FFFFFF"/>
+                    </a:solidFill>
+                  </a:tcPr>
+                </a:tc>
+              </a:tr>
+              <a:tr h="509454">
+                <a:tc>
+                  <a:txBody>
+                    <a:bodyPr wrap="square"/>
+                    <a:lstStyle/>
+                    <a:p>
+                      <a:r>
+                        <a:rPr sz="1150" b="1">
+                          <a:solidFill>
+                            <a:srgbClr val="232F3E"/>
+                          </a:solidFill>
+                          <a:latin typeface="Amazon Ember"/>
+                        </a:rPr>
+                        <a:t>组织级治理</a:t>
+                      </a:r>
+                    </a:p>
+                  </a:txBody>
+                  <a:tcPr marL="73152" marR="73152" marT="27432" marB="27432" anchor="ctr">
+                    <a:solidFill>
+                      <a:srgbClr val="F2F6FB"/>
+                    </a:solidFill>
+                  </a:tcPr>
+                </a:tc>
+                <a:tc>
+                  <a:txBody>
+                    <a:bodyPr wrap="square"/>
+                    <a:lstStyle/>
+                    <a:p>
+                      <a:r>
+                        <a:rPr sz="1150">
+                          <a:solidFill>
+                            <a:srgbClr val="1A2B4A"/>
+                          </a:solidFill>
+                          <a:latin typeface="Amazon Ember"/>
+                        </a:rPr>
+                        <a:t>SCP + IAM(账号边界)</a:t>
+                      </a:r>
+                    </a:p>
+                  </a:txBody>
+                  <a:tcPr marL="73152" marR="73152" marT="27432" marB="27432" anchor="ctr">
+                    <a:solidFill>
+                      <a:srgbClr val="F2F6FB"/>
+                    </a:solidFill>
+                  </a:tcPr>
+                </a:tc>
+                <a:tc>
+                  <a:txBody>
+                    <a:bodyPr wrap="square"/>
+                    <a:lstStyle/>
+                    <a:p>
+                      <a:r>
+                        <a:rPr sz="1150">
+                          <a:solidFill>
+                            <a:srgbClr val="1A2B4A"/>
+                          </a:solidFill>
+                          <a:latin typeface="Amazon Ember"/>
+                        </a:rPr>
+                        <a:t>IAM 层级继承(Org→Folder→Project→Bucket)</a:t>
+                      </a:r>
+                    </a:p>
+                  </a:txBody>
+                  <a:tcPr marL="73152" marR="73152" marT="27432" marB="27432" anchor="ctr">
+                    <a:solidFill>
+                      <a:srgbClr val="F2F6FB"/>
+                    </a:solidFill>
+                  </a:tcPr>
+                </a:tc>
+              </a:tr>
+            </a:tbl>
+          </a:graphicData>
+        </a:graphic>
+      </p:graphicFrame>
+      <p:sp>
+        <p:nvSpPr>
+          <p:cNvPr id="7" name="TextBox 6"/>
+          <p:cNvSpPr txBox="1"/>
+          <p:nvPr/>
+        </p:nvSpPr>
+        <p:spPr>
+          <a:xfrm>
+            <a:off x="502920" y="4983480"/>
+            <a:ext cx="11201400" cy="1417320"/>
+          </a:xfrm>
+          <a:prstGeom prst="rect">
+            <a:avLst/>
+          </a:prstGeom>
+          <a:noFill/>
+        </p:spPr>
+        <p:txBody>
+          <a:bodyPr wrap="square">
+            <a:spAutoFit/>
+          </a:bodyPr>
+          <a:lstStyle/>
+          <a:p>
+            <a:pPr>
+              <a:spcAft>
+                <a:spcPts val="400"/>
+              </a:spcAft>
+            </a:pPr>
+            <a:r>
+              <a:rPr sz="1150" b="1">
+                <a:solidFill>
+                  <a:srgbClr val="FF8500"/>
+                </a:solidFill>
+                <a:latin typeface="Amazon Ember"/>
+              </a:rPr>
+              <a:t>▸ 最大差异：S3 有「基于资源的 Bucket Policy」可直接按前缀(prefix/*)授权；GCS 无 bucket policy,前缀授权改用 IAM Conditions 的 resource.name 条件(官方支持,CEL 表达式)</a:t>
+            </a:r>
+          </a:p>
+          <a:p>
+            <a:pPr>
+              <a:spcAft>
+                <a:spcPts val="400"/>
+              </a:spcAft>
+            </a:pPr>
+            <a:r>
+              <a:rPr sz="1150" b="1">
+                <a:solidFill>
+                  <a:srgbClr val="FF8500"/>
+                </a:solidFill>
+                <a:latin typeface="Amazon Ember"/>
+              </a:rPr>
+              <a:t>▸ 别把 GCS 说成「像 S3 那样按前缀配 policy」——机制不同：S3=桶上挂 JSON policy；GCS=IAM 条件式角色绑定</a:t>
+            </a:r>
+          </a:p>
+          <a:p>
+            <a:pPr>
+              <a:spcAft>
+                <a:spcPts val="400"/>
+              </a:spcAft>
+            </a:pPr>
+            <a:r>
+              <a:rPr sz="1150" b="1">
+                <a:solidFill>
+                  <a:srgbClr val="FF8500"/>
+                </a:solidFill>
+                <a:latin typeface="Amazon Ember"/>
+              </a:rPr>
+              <a:t>▸ 两家都在推「只用 IAM、关闭对象级 ACL」的统一模型(S3 Bucket owner enforced / GCS Uniform bucket-level access)</a:t>
+            </a:r>
+          </a:p>
+        </p:txBody>
+      </p:sp>
+      <p:sp>
+        <p:nvSpPr>
+          <p:cNvPr id="8" name="TextBox 7"/>
+          <p:cNvSpPr txBox="1"/>
+          <p:nvPr/>
+        </p:nvSpPr>
+        <p:spPr>
+          <a:xfrm>
+            <a:off x="11292840" y="6428232"/>
+            <a:ext cx="685800" cy="320040"/>
+          </a:xfrm>
+          <a:prstGeom prst="rect">
+            <a:avLst/>
+          </a:prstGeom>
+          <a:noFill/>
+        </p:spPr>
+        <p:txBody>
+          <a:bodyPr wrap="square" anchor="t">
+            <a:spAutoFit/>
+          </a:bodyPr>
+          <a:lstStyle/>
+          <a:p>
+            <a:pPr algn="r"/>
+            <a:r>
+              <a:rPr sz="1100" b="0">
+                <a:solidFill>
+                  <a:srgbClr val="5A6B82"/>
+                </a:solidFill>
+                <a:latin typeface="Amazon Ember"/>
+              </a:rPr>
+              <a:t>12</a:t>
             </a:r>
           </a:p>
         </p:txBody>

</xml_diff>